<commit_message>
Fixed some tests, added report
</commit_message>
<xml_diff>
--- a/docs/מצגת.pptx
+++ b/docs/מצגת.pptx
@@ -226,7 +226,7 @@
           <a:p>
             <a:fld id="{FD913024-4032-4B4F-8680-09D5E08EDB6E}" type="datetimeFigureOut">
               <a:rPr lang="en-US" smtClean="0"/>
-              <a:t>1/1/2026</a:t>
+              <a:t>1/3/2026</a:t>
             </a:fld>
             <a:endParaRPr lang="en-US" dirty="0"/>
           </a:p>
@@ -403,7 +403,7 @@
           <a:p>
             <a:fld id="{F2AE225E-43E0-7047-8ADB-DD9EBB41B4D0}" type="datetimeFigureOut">
               <a:rPr lang="en-US" noProof="0" smtClean="0"/>
-              <a:t>1/1/2026</a:t>
+              <a:t>1/3/2026</a:t>
             </a:fld>
             <a:endParaRPr lang="en-US" noProof="0" dirty="0"/>
           </a:p>
@@ -27633,7 +27633,7 @@
             <p:ph sz="quarter" idx="13"/>
             <p:extLst>
               <p:ext uri="{D42A27DB-BD31-4B8C-83A1-F6EECF244321}">
-                <p14:modId xmlns:p14="http://schemas.microsoft.com/office/powerpoint/2010/main" val="2931586517"/>
+                <p14:modId xmlns:p14="http://schemas.microsoft.com/office/powerpoint/2010/main" val="3710230206"/>
               </p:ext>
             </p:extLst>
           </p:nvPr>
@@ -27700,8 +27700,12 @@
                     <a:p>
                       <a:pPr algn="l" rtl="0"/>
                       <a:r>
+                        <a:rPr lang="en-US" sz="2000" b="0"/>
+                        <a:t>ATTEMPTS </a:t>
+                      </a:r>
+                      <a:r>
                         <a:rPr lang="en-US" sz="2000" b="0" dirty="0"/>
-                        <a:t>ATTEMTPS / SEC</a:t>
+                        <a:t>/ SEC</a:t>
                       </a:r>
                     </a:p>
                   </a:txBody>
@@ -27714,9 +27718,21 @@
                     <a:p>
                       <a:pPr algn="l" rtl="0"/>
                       <a:r>
-                        <a:rPr lang="en-US" sz="2000" b="0" dirty="0"/>
-                        <a:t>TTFS</a:t>
+                        <a:rPr lang="en-US" sz="2000" b="0"/>
+                        <a:t>TTFS </a:t>
                       </a:r>
+                      <a:br>
+                        <a:rPr lang="en-US" sz="2000" b="0"/>
+                      </a:br>
+                      <a:r>
+                        <a:rPr lang="en-US" sz="900" b="0"/>
+                        <a:t>Time </a:t>
+                      </a:r>
+                      <a:r>
+                        <a:rPr lang="en-US" sz="900" b="0" dirty="0"/>
+                        <a:t>To First Success</a:t>
+                      </a:r>
+                      <a:endParaRPr lang="en-US" sz="2000" b="0" dirty="0"/>
                     </a:p>
                   </a:txBody>
                   <a:tcPr anchor="ctr"/>
@@ -29389,13 +29405,13 @@
         </p:spPr>
         <p:txBody>
           <a:bodyPr>
-            <a:normAutofit lnSpcReduction="10000"/>
+            <a:normAutofit fontScale="92500" lnSpcReduction="10000"/>
           </a:bodyPr>
           <a:lstStyle/>
           <a:p>
             <a:pPr algn="r" rtl="1">
               <a:lnSpc>
-                <a:spcPct val="150000"/>
+                <a:spcPct val="160000"/>
               </a:lnSpc>
               <a:spcBef>
                 <a:spcPts val="600"/>
@@ -29463,7 +29479,7 @@
           <a:p>
             <a:pPr algn="r" rtl="1">
               <a:lnSpc>
-                <a:spcPct val="150000"/>
+                <a:spcPct val="160000"/>
               </a:lnSpc>
               <a:spcBef>
                 <a:spcPts val="600"/>
@@ -29510,7 +29526,7 @@
           <a:p>
             <a:pPr algn="r" rtl="1">
               <a:lnSpc>
-                <a:spcPct val="150000"/>
+                <a:spcPct val="160000"/>
               </a:lnSpc>
               <a:spcBef>
                 <a:spcPts val="600"/>
@@ -29574,7 +29590,7 @@
           <a:p>
             <a:pPr algn="r" rtl="1">
               <a:lnSpc>
-                <a:spcPct val="150000"/>
+                <a:spcPct val="160000"/>
               </a:lnSpc>
               <a:spcBef>
                 <a:spcPts val="600"/>
@@ -30352,8 +30368,8 @@
           </a:p>
         </p:txBody>
       </p:sp>
-      <mc:AlternateContent xmlns:mc="http://schemas.openxmlformats.org/markup-compatibility/2006">
-        <mc:Choice xmlns:a14="http://schemas.microsoft.com/office/drawing/2010/main" Requires="a14">
+      <mc:AlternateContent xmlns:mc="http://schemas.openxmlformats.org/markup-compatibility/2006" xmlns:a14="http://schemas.microsoft.com/office/drawing/2010/main">
+        <mc:Choice Requires="a14">
           <p:sp>
             <p:nvSpPr>
               <p:cNvPr id="25" name="Content Placeholder 24">
@@ -30608,7 +30624,7 @@
             </p:txBody>
           </p:sp>
         </mc:Choice>
-        <mc:Fallback>
+        <mc:Fallback xmlns="">
           <p:sp>
             <p:nvSpPr>
               <p:cNvPr id="25" name="Content Placeholder 24">
@@ -30972,7 +30988,7 @@
             <p:ph sz="quarter" idx="13"/>
             <p:extLst>
               <p:ext uri="{D42A27DB-BD31-4B8C-83A1-F6EECF244321}">
-                <p14:modId xmlns:p14="http://schemas.microsoft.com/office/powerpoint/2010/main" val="1415733711"/>
+                <p14:modId xmlns:p14="http://schemas.microsoft.com/office/powerpoint/2010/main" val="2052163539"/>
               </p:ext>
             </p:extLst>
           </p:nvPr>
@@ -31040,7 +31056,7 @@
                       <a:pPr algn="l" rtl="0"/>
                       <a:r>
                         <a:rPr lang="en-US" sz="2000" b="0" dirty="0"/>
-                        <a:t>ATTEMTPS / SEC</a:t>
+                        <a:t>ATTEMPTS / SEC</a:t>
                       </a:r>
                     </a:p>
                   </a:txBody>
@@ -31583,7 +31599,7 @@
             <p:ph sz="quarter" idx="13"/>
             <p:extLst>
               <p:ext uri="{D42A27DB-BD31-4B8C-83A1-F6EECF244321}">
-                <p14:modId xmlns:p14="http://schemas.microsoft.com/office/powerpoint/2010/main" val="3049279267"/>
+                <p14:modId xmlns:p14="http://schemas.microsoft.com/office/powerpoint/2010/main" val="1197483526"/>
               </p:ext>
             </p:extLst>
           </p:nvPr>
@@ -31651,7 +31667,7 @@
                       <a:pPr algn="l" rtl="0"/>
                       <a:r>
                         <a:rPr lang="en-US" sz="2000" b="0" dirty="0"/>
-                        <a:t>ATTEMTPS / SEC</a:t>
+                        <a:t>ATTEMPTS / SEC</a:t>
                       </a:r>
                     </a:p>
                   </a:txBody>

</xml_diff>